<commit_message>
chore(craft): remove commercial embedded fonts from built-in templates
Replace all commercial/non-installed fonts in the baked pptx templates with
fonts the sandbox already installs, so nothing commercial is redistributed and
everything renders correctly in-sandbox:
- pitch-deck: strip embedded Kabel/Loubag, remap to Montserrat
- presentation-template: strip embedded fonts, remap Roboto/Open Sans/Nunito/PT
  Sans to Inter
- all-hands-template: remap theme major/minor (Century Gothic/Aptos) to Calibri

All three now embed no fonts and stay under the 1.5MB file limit.

Co-Authored-By: Claude Opus 4.8 (1M context) <noreply@anthropic.com>
</commit_message>
<xml_diff>
--- a/backend/onyx/server/features/build/sandbox/image/templates/pptx/all-hands-template.pptx
+++ b/backend/onyx/server/features/build/sandbox/image/templates/pptx/all-hands-template.pptx
@@ -6397,7 +6397,7 @@
               <a:effectLst/>
               <a:uLnTx/>
               <a:uFillTx/>
-              <a:latin typeface="Century Gothic" panose="020B0502020202020204"/>
+              <a:latin typeface="Calibri" panose="020B0502020202020204"/>
               <a:ea typeface="+mn-ea"/>
               <a:cs typeface="+mn-cs"/>
             </a:endParaRPr>
@@ -6490,7 +6490,7 @@
               <a:effectLst/>
               <a:uLnTx/>
               <a:uFillTx/>
-              <a:latin typeface="Century Gothic" panose="020B0502020202020204"/>
+              <a:latin typeface="Calibri" panose="020B0502020202020204"/>
               <a:ea typeface="+mn-ea"/>
               <a:cs typeface="+mn-cs"/>
             </a:endParaRPr>
@@ -6976,7 +6976,7 @@
               <a:effectLst/>
               <a:uLnTx/>
               <a:uFillTx/>
-              <a:latin typeface="Century Gothic" panose="020B0502020202020204"/>
+              <a:latin typeface="Calibri" panose="020B0502020202020204"/>
               <a:ea typeface="+mn-ea"/>
               <a:cs typeface="+mn-cs"/>
             </a:endParaRPr>
@@ -7211,7 +7211,7 @@
                 <a:effectLst/>
                 <a:uLnTx/>
                 <a:uFillTx/>
-                <a:latin typeface="Century Gothic" panose="020B0502020202020204"/>
+                <a:latin typeface="Calibri" panose="020B0502020202020204"/>
                 <a:ea typeface="+mn-ea"/>
                 <a:cs typeface="+mn-cs"/>
               </a:endParaRPr>
@@ -7332,7 +7332,7 @@
                 <a:effectLst/>
                 <a:uLnTx/>
                 <a:uFillTx/>
-                <a:latin typeface="Century Gothic" panose="020B0502020202020204"/>
+                <a:latin typeface="Calibri" panose="020B0502020202020204"/>
                 <a:ea typeface="+mn-ea"/>
                 <a:cs typeface="+mn-cs"/>
               </a:endParaRPr>
@@ -7596,7 +7596,7 @@
               <a:effectLst/>
               <a:uLnTx/>
               <a:uFillTx/>
-              <a:latin typeface="Century Gothic" panose="020B0502020202020204"/>
+              <a:latin typeface="Calibri" panose="020B0502020202020204"/>
               <a:ea typeface="+mn-ea"/>
               <a:cs typeface="+mn-cs"/>
             </a:endParaRPr>
@@ -7690,7 +7690,7 @@
               <a:effectLst/>
               <a:uLnTx/>
               <a:uFillTx/>
-              <a:latin typeface="Century Gothic" panose="020B0502020202020204"/>
+              <a:latin typeface="Calibri" panose="020B0502020202020204"/>
               <a:ea typeface="+mn-ea"/>
               <a:cs typeface="+mn-cs"/>
             </a:endParaRPr>
@@ -8224,7 +8224,7 @@
               <a:effectLst/>
               <a:uLnTx/>
               <a:uFillTx/>
-              <a:latin typeface="Century Gothic" panose="020B0502020202020204"/>
+              <a:latin typeface="Calibri" panose="020B0502020202020204"/>
               <a:ea typeface="+mn-ea"/>
               <a:cs typeface="+mn-cs"/>
             </a:endParaRPr>
@@ -8520,7 +8520,7 @@
               <a:effectLst/>
               <a:uLnTx/>
               <a:uFillTx/>
-              <a:latin typeface="Century Gothic" panose="020B0502020202020204"/>
+              <a:latin typeface="Calibri" panose="020B0502020202020204"/>
               <a:ea typeface="+mn-ea"/>
               <a:cs typeface="+mn-cs"/>
             </a:endParaRPr>
@@ -8834,7 +8834,7 @@
               <a:effectLst/>
               <a:uLnTx/>
               <a:uFillTx/>
-              <a:latin typeface="Century Gothic" panose="020B0502020202020204"/>
+              <a:latin typeface="Calibri" panose="020B0502020202020204"/>
               <a:ea typeface="+mn-ea"/>
               <a:cs typeface="+mn-cs"/>
             </a:endParaRPr>
@@ -9185,7 +9185,7 @@
               <a:effectLst/>
               <a:uLnTx/>
               <a:uFillTx/>
-              <a:latin typeface="Century Gothic" panose="020B0502020202020204"/>
+              <a:latin typeface="Calibri" panose="020B0502020202020204"/>
               <a:ea typeface="+mn-ea"/>
               <a:cs typeface="+mn-cs"/>
             </a:endParaRPr>
@@ -9667,7 +9667,7 @@
               <a:effectLst/>
               <a:uLnTx/>
               <a:uFillTx/>
-              <a:latin typeface="Century Gothic" panose="020B0502020202020204"/>
+              <a:latin typeface="Calibri" panose="020B0502020202020204"/>
               <a:ea typeface="+mn-ea"/>
               <a:cs typeface="+mn-cs"/>
             </a:endParaRPr>
@@ -10072,7 +10072,7 @@
               <a:effectLst/>
               <a:uLnTx/>
               <a:uFillTx/>
-              <a:latin typeface="Century Gothic" panose="020B0502020202020204"/>
+              <a:latin typeface="Calibri" panose="020B0502020202020204"/>
               <a:ea typeface="+mn-ea"/>
               <a:cs typeface="+mn-cs"/>
             </a:endParaRPr>
@@ -10165,7 +10165,7 @@
               <a:effectLst/>
               <a:uLnTx/>
               <a:uFillTx/>
-              <a:latin typeface="Century Gothic" panose="020B0502020202020204"/>
+              <a:latin typeface="Calibri" panose="020B0502020202020204"/>
               <a:ea typeface="+mn-ea"/>
               <a:cs typeface="+mn-cs"/>
             </a:endParaRPr>
@@ -10705,7 +10705,7 @@
                 <a:effectLst/>
                 <a:uLnTx/>
                 <a:uFillTx/>
-                <a:latin typeface="Century Gothic" panose="020B0502020202020204"/>
+                <a:latin typeface="Calibri" panose="020B0502020202020204"/>
                 <a:ea typeface="+mn-ea"/>
                 <a:cs typeface="+mn-cs"/>
               </a:rPr>
@@ -11220,7 +11220,7 @@
               <a:effectLst/>
               <a:uLnTx/>
               <a:uFillTx/>
-              <a:latin typeface="Century Gothic" panose="020B0502020202020204"/>
+              <a:latin typeface="Calibri" panose="020B0502020202020204"/>
               <a:ea typeface="+mn-ea"/>
               <a:cs typeface="+mn-cs"/>
             </a:endParaRPr>
@@ -11313,7 +11313,7 @@
               <a:effectLst/>
               <a:uLnTx/>
               <a:uFillTx/>
-              <a:latin typeface="Century Gothic" panose="020B0502020202020204"/>
+              <a:latin typeface="Calibri" panose="020B0502020202020204"/>
               <a:ea typeface="+mn-ea"/>
               <a:cs typeface="+mn-cs"/>
             </a:endParaRPr>
@@ -11885,7 +11885,7 @@
               <a:effectLst/>
               <a:uLnTx/>
               <a:uFillTx/>
-              <a:latin typeface="Century Gothic" panose="020B0502020202020204"/>
+              <a:latin typeface="Calibri" panose="020B0502020202020204"/>
               <a:ea typeface="+mn-ea"/>
               <a:cs typeface="+mn-cs"/>
             </a:endParaRPr>
@@ -15342,7 +15342,7 @@
     </a:clrScheme>
     <a:fontScheme name="Quotable">
       <a:majorFont>
-        <a:latin typeface="Century Gothic" panose="020B0502020202020204"/>
+        <a:latin typeface="Calibri" panose="020B0502020202020204"/>
         <a:ea typeface=""/>
         <a:cs typeface=""/>
         <a:font script="Jpan" typeface="ＭＳ ゴシック"/>
@@ -15377,7 +15377,7 @@
         <a:font script="Geor" typeface="Sylfaen"/>
       </a:majorFont>
       <a:minorFont>
-        <a:latin typeface="Century Gothic" panose="020B0502020202020204"/>
+        <a:latin typeface="Calibri" panose="020B0502020202020204"/>
         <a:ea typeface=""/>
         <a:cs typeface=""/>
         <a:font script="Jpan" typeface="ＭＳ ゴシック"/>
@@ -15874,7 +15874,7 @@
     </a:clrScheme>
     <a:fontScheme name="Office">
       <a:majorFont>
-        <a:latin typeface="Aptos Display" panose="02110004020202020204"/>
+        <a:latin typeface="Calibri" panose="02110004020202020204"/>
         <a:ea typeface=""/>
         <a:cs typeface=""/>
         <a:font script="Jpan" typeface="游ゴシック Light"/>
@@ -15926,7 +15926,7 @@
         <a:font script="Tfng" typeface="Ebrima"/>
       </a:majorFont>
       <a:minorFont>
-        <a:latin typeface="Aptos" panose="02110004020202020204"/>
+        <a:latin typeface="Calibri" panose="02110004020202020204"/>
         <a:ea typeface=""/>
         <a:cs typeface=""/>
         <a:font script="Jpan" typeface="游ゴシック"/>

</xml_diff>